<commit_message>
Mise a jour README (badge CI) et slides (mention integration continue)
</commit_message>
<xml_diff>
--- a/De_la_Donnee_a_la_Decision_Slides.pptx
+++ b/De_la_Donnee_a_la_Decision_Slides.pptx
@@ -2962,7 +2962,7 @@
                 <a:ea typeface="Calibri" pitchFamily="34" charset="-122"/>
                 <a:cs typeface="Calibri" pitchFamily="34" charset="-120"/>
               </a:rPr>
-              <a:t>pytest passants</a:t>
+              <a:t>pytest passants en CI (GitHub Actions)</a:t>
             </a:r>
             <a:endParaRPr lang="en-US" sz="1100" dirty="0"/>
           </a:p>
@@ -9724,7 +9724,7 @@
         </p:nvSpPr>
         <p:spPr>
           <a:xfrm>
-            <a:off x="7772400" y="2057400"/>
+            <a:off x="7772400" y="2011680"/>
             <a:ext cx="3657600" cy="365760"/>
           </a:xfrm>
           <a:prstGeom prst="rect">
@@ -9763,8 +9763,8 @@
         </p:nvSpPr>
         <p:spPr>
           <a:xfrm>
-            <a:off x="7772400" y="2606040"/>
-            <a:ext cx="365760" cy="457200"/>
+            <a:off x="7772400" y="2514600"/>
+            <a:ext cx="365760" cy="411480"/>
           </a:xfrm>
           <a:prstGeom prst="rect">
             <a:avLst/>
@@ -9802,8 +9802,8 @@
         </p:nvSpPr>
         <p:spPr>
           <a:xfrm>
-            <a:off x="8183880" y="2606040"/>
-            <a:ext cx="3200400" cy="731520"/>
+            <a:off x="8183880" y="2514600"/>
+            <a:ext cx="3291840" cy="640080"/>
           </a:xfrm>
           <a:prstGeom prst="rect">
             <a:avLst/>
@@ -9819,7 +9819,7 @@
               <a:buNone/>
             </a:pPr>
             <a:r>
-              <a:rPr lang="en-US" sz="1250" dirty="0">
+              <a:rPr lang="en-US" sz="1200" dirty="0">
                 <a:solidFill>
                   <a:srgbClr val="CADCFC"/>
                 </a:solidFill>
@@ -9829,7 +9829,7 @@
               </a:rPr>
               <a:t>6 / 6 tests pytest passants</a:t>
             </a:r>
-            <a:endParaRPr lang="en-US" sz="1250" dirty="0"/>
+            <a:endParaRPr lang="en-US" sz="1200" dirty="0"/>
           </a:p>
         </p:txBody>
       </p:sp>
@@ -9841,8 +9841,8 @@
         </p:nvSpPr>
         <p:spPr>
           <a:xfrm>
-            <a:off x="7772400" y="3474720"/>
-            <a:ext cx="365760" cy="457200"/>
+            <a:off x="7772400" y="3227832"/>
+            <a:ext cx="365760" cy="411480"/>
           </a:xfrm>
           <a:prstGeom prst="rect">
             <a:avLst/>
@@ -9880,8 +9880,8 @@
         </p:nvSpPr>
         <p:spPr>
           <a:xfrm>
-            <a:off x="8183880" y="3474720"/>
-            <a:ext cx="3200400" cy="731520"/>
+            <a:off x="8183880" y="3227832"/>
+            <a:ext cx="3291840" cy="640080"/>
           </a:xfrm>
           <a:prstGeom prst="rect">
             <a:avLst/>
@@ -9897,7 +9897,7 @@
               <a:buNone/>
             </a:pPr>
             <a:r>
-              <a:rPr lang="en-US" sz="1250" dirty="0">
+              <a:rPr lang="en-US" sz="1200" dirty="0">
                 <a:solidFill>
                   <a:srgbClr val="CADCFC"/>
                 </a:solidFill>
@@ -9905,22 +9905,100 @@
                 <a:ea typeface="Calibri" pitchFamily="34" charset="-122"/>
                 <a:cs typeface="Calibri" pitchFamily="34" charset="-120"/>
               </a:rPr>
+              <a:t>Intégration continue (GitHub Actions) : tests rejoués à chaque push</a:t>
+            </a:r>
+            <a:endParaRPr lang="en-US" sz="1200" dirty="0"/>
+          </a:p>
+        </p:txBody>
+      </p:sp>
+      <p:sp>
+        <p:nvSpPr>
+          <p:cNvPr id="25" name="Text 23"/>
+          <p:cNvSpPr/>
+          <p:nvPr/>
+        </p:nvSpPr>
+        <p:spPr>
+          <a:xfrm>
+            <a:off x="7772400" y="3941064"/>
+            <a:ext cx="365760" cy="411480"/>
+          </a:xfrm>
+          <a:prstGeom prst="rect">
+            <a:avLst/>
+          </a:prstGeom>
+          <a:noFill/>
+          <a:ln/>
+        </p:spPr>
+        <p:txBody>
+          <a:bodyPr wrap="square" rtlCol="0" anchor="ctr"/>
+          <a:lstStyle/>
+          <a:p>
+            <a:pPr indent="0" marL="0">
+              <a:buNone/>
+            </a:pPr>
+            <a:r>
+              <a:rPr lang="en-US" sz="1600" b="1" dirty="0">
+                <a:solidFill>
+                  <a:srgbClr val="D4A017"/>
+                </a:solidFill>
+                <a:latin typeface="Calibri" pitchFamily="34" charset="0"/>
+                <a:ea typeface="Calibri" pitchFamily="34" charset="-122"/>
+                <a:cs typeface="Calibri" pitchFamily="34" charset="-120"/>
+              </a:rPr>
+              <a:t>✓</a:t>
+            </a:r>
+            <a:endParaRPr lang="en-US" sz="1600" dirty="0"/>
+          </a:p>
+        </p:txBody>
+      </p:sp>
+      <p:sp>
+        <p:nvSpPr>
+          <p:cNvPr id="26" name="Text 24"/>
+          <p:cNvSpPr/>
+          <p:nvPr/>
+        </p:nvSpPr>
+        <p:spPr>
+          <a:xfrm>
+            <a:off x="8183880" y="3941064"/>
+            <a:ext cx="3291840" cy="640080"/>
+          </a:xfrm>
+          <a:prstGeom prst="rect">
+            <a:avLst/>
+          </a:prstGeom>
+          <a:noFill/>
+          <a:ln/>
+        </p:spPr>
+        <p:txBody>
+          <a:bodyPr wrap="square" rtlCol="0" anchor="t"/>
+          <a:lstStyle/>
+          <a:p>
+            <a:pPr indent="0" marL="0">
+              <a:buNone/>
+            </a:pPr>
+            <a:r>
+              <a:rPr lang="en-US" sz="1200" dirty="0">
+                <a:solidFill>
+                  <a:srgbClr val="CADCFC"/>
+                </a:solidFill>
+                <a:latin typeface="Calibri" pitchFamily="34" charset="0"/>
+                <a:ea typeface="Calibri" pitchFamily="34" charset="-122"/>
+                <a:cs typeface="Calibri" pitchFamily="34" charset="-120"/>
+              </a:rPr>
               <a:t>Pipeline sérialisé, rechargement déterministe vérifié</a:t>
             </a:r>
-            <a:endParaRPr lang="en-US" sz="1250" dirty="0"/>
-          </a:p>
-        </p:txBody>
-      </p:sp>
-      <p:sp>
-        <p:nvSpPr>
-          <p:cNvPr id="25" name="Text 23"/>
-          <p:cNvSpPr/>
-          <p:nvPr/>
-        </p:nvSpPr>
-        <p:spPr>
-          <a:xfrm>
-            <a:off x="7772400" y="4343400"/>
-            <a:ext cx="365760" cy="457200"/>
+            <a:endParaRPr lang="en-US" sz="1200" dirty="0"/>
+          </a:p>
+        </p:txBody>
+      </p:sp>
+      <p:sp>
+        <p:nvSpPr>
+          <p:cNvPr id="27" name="Text 25"/>
+          <p:cNvSpPr/>
+          <p:nvPr/>
+        </p:nvSpPr>
+        <p:spPr>
+          <a:xfrm>
+            <a:off x="7772400" y="4654296"/>
+            <a:ext cx="365760" cy="411480"/>
           </a:xfrm>
           <a:prstGeom prst="rect">
             <a:avLst/>
@@ -9952,14 +10030,14 @@
       </p:sp>
       <p:sp>
         <p:nvSpPr>
-          <p:cNvPr id="26" name="Text 24"/>
-          <p:cNvSpPr/>
-          <p:nvPr/>
-        </p:nvSpPr>
-        <p:spPr>
-          <a:xfrm>
-            <a:off x="8183880" y="4343400"/>
-            <a:ext cx="3200400" cy="731520"/>
+          <p:cNvPr id="28" name="Text 26"/>
+          <p:cNvSpPr/>
+          <p:nvPr/>
+        </p:nvSpPr>
+        <p:spPr>
+          <a:xfrm>
+            <a:off x="8183880" y="4654296"/>
+            <a:ext cx="3291840" cy="640080"/>
           </a:xfrm>
           <a:prstGeom prst="rect">
             <a:avLst/>
@@ -9975,7 +10053,7 @@
               <a:buNone/>
             </a:pPr>
             <a:r>
-              <a:rPr lang="en-US" sz="1250" dirty="0">
+              <a:rPr lang="en-US" sz="1200" dirty="0">
                 <a:solidFill>
                   <a:srgbClr val="CADCFC"/>
                 </a:solidFill>
@@ -9985,20 +10063,20 @@
               </a:rPr>
               <a:t>README + model card documentés</a:t>
             </a:r>
-            <a:endParaRPr lang="en-US" sz="1250" dirty="0"/>
-          </a:p>
-        </p:txBody>
-      </p:sp>
-      <p:sp>
-        <p:nvSpPr>
-          <p:cNvPr id="27" name="Text 25"/>
-          <p:cNvSpPr/>
-          <p:nvPr/>
-        </p:nvSpPr>
-        <p:spPr>
-          <a:xfrm>
-            <a:off x="7772400" y="5212080"/>
-            <a:ext cx="365760" cy="457200"/>
+            <a:endParaRPr lang="en-US" sz="1200" dirty="0"/>
+          </a:p>
+        </p:txBody>
+      </p:sp>
+      <p:sp>
+        <p:nvSpPr>
+          <p:cNvPr id="29" name="Text 27"/>
+          <p:cNvSpPr/>
+          <p:nvPr/>
+        </p:nvSpPr>
+        <p:spPr>
+          <a:xfrm>
+            <a:off x="7772400" y="5367528"/>
+            <a:ext cx="365760" cy="411480"/>
           </a:xfrm>
           <a:prstGeom prst="rect">
             <a:avLst/>
@@ -10030,14 +10108,14 @@
       </p:sp>
       <p:sp>
         <p:nvSpPr>
-          <p:cNvPr id="28" name="Text 26"/>
-          <p:cNvSpPr/>
-          <p:nvPr/>
-        </p:nvSpPr>
-        <p:spPr>
-          <a:xfrm>
-            <a:off x="8183880" y="5212080"/>
-            <a:ext cx="3200400" cy="731520"/>
+          <p:cNvPr id="30" name="Text 28"/>
+          <p:cNvSpPr/>
+          <p:nvPr/>
+        </p:nvSpPr>
+        <p:spPr>
+          <a:xfrm>
+            <a:off x="8183880" y="5367528"/>
+            <a:ext cx="3291840" cy="640080"/>
           </a:xfrm>
           <a:prstGeom prst="rect">
             <a:avLst/>
@@ -10053,7 +10131,7 @@
               <a:buNone/>
             </a:pPr>
             <a:r>
-              <a:rPr lang="en-US" sz="1250" dirty="0">
+              <a:rPr lang="en-US" sz="1200" dirty="0">
                 <a:solidFill>
                   <a:srgbClr val="CADCFC"/>
                 </a:solidFill>
@@ -10063,13 +10141,13 @@
               </a:rPr>
               <a:t>Plan de monitoring (data / concept / performance drift)</a:t>
             </a:r>
-            <a:endParaRPr lang="en-US" sz="1250" dirty="0"/>
-          </a:p>
-        </p:txBody>
-      </p:sp>
-      <p:sp>
-        <p:nvSpPr>
-          <p:cNvPr id="29" name="Text 27"/>
+            <a:endParaRPr lang="en-US" sz="1200" dirty="0"/>
+          </a:p>
+        </p:txBody>
+      </p:sp>
+      <p:sp>
+        <p:nvSpPr>
+          <p:cNvPr id="31" name="Text 29"/>
           <p:cNvSpPr/>
           <p:nvPr/>
         </p:nvSpPr>
@@ -10108,7 +10186,7 @@
       </p:sp>
       <p:sp>
         <p:nvSpPr>
-          <p:cNvPr id="30" name="Text 28"/>
+          <p:cNvPr id="32" name="Text 30"/>
           <p:cNvSpPr/>
           <p:nvPr/>
         </p:nvSpPr>

</xml_diff>